<commit_message>
feat: replace Streamlit demo with custom BERT web interface
</commit_message>
<xml_diff>
--- a/presentation/BERT_Project_Final.pptx
+++ b/presentation/BERT_Project_Final.pptx
@@ -29252,7 +29252,7 @@
                   <a:srgbClr val="2D3748"/>
                 </a:solidFill>
               </a:rPr>
-              <a:t> Đóng băng và kiểm thử trên Held-Out Test Set (3,949 mẫu); phân tích định tính ca lỗi và đóng gói Web UI Streamlit.</a:t>
+              <a:t> Đóng băng và kiểm thử trên Held-Out Test Set (3,949 mẫu); phân tích định tính ca lỗi và đóng gói Web UI FastAPI.</a:t>
             </a:r>
           </a:p>
         </p:txBody>
@@ -30587,7 +30587,7 @@
             </a:r>
             <a:br/>
             <a:r>
-              <a:t>Web UI Streamlit</a:t>
+              <a:t>Web UI FastAPI</a:t>
             </a:r>
           </a:p>
         </p:txBody>
@@ -35711,7 +35711,7 @@
               </a:defRPr>
             </a:pPr>
             <a:r>
-              <a:t>ỨNG DỤNG TƯƠNG TÁC THỜI GIAN THỰC (STREAMLIT DEMO)</a:t>
+              <a:t>ỨNG DỤNG TƯƠNG TÁC THỜI GIAN THỰC (FASTAPI DEMO)</a:t>
             </a:r>
           </a:p>
         </p:txBody>
@@ -35991,7 +35991,7 @@
               </a:defRPr>
             </a:pPr>
             <a:r>
-              <a:t>GIAO DIỆN ỨNG DỤNG WEB (STREAMLIT UI — app/app.py)</a:t>
+              <a:t>GIAO DIỆN ỨNG DỤNG WEB (FASTAPI UI — app/main.py)</a:t>
             </a:r>
           </a:p>
         </p:txBody>
@@ -36076,7 +36076,7 @@
               </a:defRPr>
             </a:pPr>
             <a:r>
-              <a:t>• Nhãn dự đoán và độ tin cậy của BERT cùng Baseline.</a:t>
+              <a:t>• Nhãn dự đoán và độ tin cậy từ BERT.</a:t>
             </a:r>
           </a:p>
           <a:p>
@@ -36089,7 +36089,7 @@
               </a:defRPr>
             </a:pPr>
             <a:r>
-              <a:t>• Danh sách token WordPiece của văn bản đầu vào.</a:t>
+              <a:t>• Thanh xác suất Positive / Negative từ đầu ra thực tế.</a:t>
             </a:r>
           </a:p>
           <a:p>
@@ -36102,7 +36102,7 @@
               </a:defRPr>
             </a:pPr>
             <a:r>
-              <a:t>• Độ trễ suy luận đo trực tiếp, phụ thuộc phần cứng và môi trường.</a:t>
+              <a:t>• Trạng thái tải và thông báo lỗi rõ ràng, không lộ stack trace.</a:t>
             </a:r>
           </a:p>
         </p:txBody>
@@ -36200,7 +36200,7 @@
               </a:defRPr>
             </a:pPr>
             <a:r>
-              <a:t>TRIỂN KHAI CỤC BỘ KHÉP KÍN</a:t>
+              <a:t>TRIỂN KHAI CỤC BỘ NHẸ</a:t>
             </a:r>
           </a:p>
         </p:txBody>
@@ -36236,7 +36236,7 @@
               </a:defRPr>
             </a:pPr>
             <a:r>
-              <a:t>• Nạp tự động trọng số đã đóng băng từ artifacts/model/bert_best_model/.</a:t>
+              <a:t>• FastAPI phục vụ trang Jinja2 và endpoint POST /api/predict.</a:t>
             </a:r>
           </a:p>
           <a:p>
@@ -36249,7 +36249,7 @@
               </a:defRPr>
             </a:pPr>
             <a:r>
-              <a:t>• Đo lường và hiển thị độ trễ suy luận thời gian thực (Inference Latency ms).</a:t>
+              <a:t>• Pipeline chuẩn cache model/tokenizer, không nạp lại mỗi request.</a:t>
             </a:r>
           </a:p>
         </p:txBody>
@@ -36347,7 +36347,7 @@
               </a:defRPr>
             </a:pPr>
             <a:r>
-              <a:t>SO SÁNH ĐỐI ĐẦU SONG SONG</a:t>
+              <a:t>KẾT QUẢ MÔ HÌNH THỰC</a:t>
             </a:r>
           </a:p>
         </p:txBody>
@@ -36383,7 +36383,7 @@
               </a:defRPr>
             </a:pPr>
             <a:r>
-              <a:t>• Cho phép thử nghiệm trực tiếp khả năng nắm bắt ngữ cảnh câu giữa TF-IDF và Transformer trên cùng một văn bản đầu vào.</a:t>
+              <a:t>• Nhãn, độ tin cậy và hai xác suất được lấy từ src.predict.predict_bert, không dùng giá trị minh họa.</a:t>
             </a:r>
           </a:p>
         </p:txBody>
@@ -36481,7 +36481,7 @@
               </a:defRPr>
             </a:pPr>
             <a:r>
-              <a:t>TRỰC QUAN HÓA CƠ CHẾ BERT</a:t>
+              <a:t>TRẢI NGHIỆM THUYẾT TRÌNH</a:t>
             </a:r>
           </a:p>
         </p:txBody>
@@ -36517,7 +36517,7 @@
               </a:defRPr>
             </a:pPr>
             <a:r>
-              <a:t>• Hiển thị danh sách token WordPiece (##), minh họa trực quan cơ chế tách từ và biểu diễn vector cho người sử dụng.</a:t>
+              <a:t>• Ví dụ viết thủ công, bộ đếm ký tự, trạng thái tải và xử lý lỗi thân thiện trên một trang responsive.</a:t>
             </a:r>
           </a:p>
         </p:txBody>

</xml_diff>